<commit_message>
Update: Add PT Sinergi Gula Nusantara (SGN) data slide
- Added Slide 15: PT SGN / SugarCo overview with unit kerja info
  - 43 Pabrik Gula, 56.000 ha areal, 7 PTPN subsidiaries
  - Regional breakdown (Jatim, Jateng, Jabar, Lampung/luar Jawa)
  - Strategic initiatives: bioethanol, KHDTK, digitalization
- Updated summary slide with SGN data point
- Source: sinergigula.com, The Jakarta Post, UGM.ac.id
- Total slides: 17 (was 16)
</commit_message>
<xml_diff>
--- a/Overview_Proses_Alur_Bisnis_Pabrik_Gula.pptx
+++ b/Overview_Proses_Alur_Bisnis_Pabrik_Gula.pptx
@@ -19,8 +19,9 @@
     <p:sldId id="267" r:id="rId18"/>
     <p:sldId id="268" r:id="rId19"/>
     <p:sldId id="269" r:id="rId20"/>
-    <p:sldId id="270" r:id="rId21"/>
-    <p:sldId id="271" r:id="rId22"/>
+    <p:sldId id="272" r:id="rId23"/>
+    <p:sldId id="273" r:id="rId24"/>
+    <p:sldId id="274" r:id="rId25"/>
   </p:sldIdLst>
   <p:sldSz cx="12191695" cy="6858000" type="screen4x3"/>
   <p:notesSz cx="6858000" cy="9144000"/>
@@ -7113,7 +7114,7 @@
 </p:sld>
 </file>
 
-<file path=ppt/slides/slide15.xml><?xml version="1.0" encoding="utf-8"?>
+<file path=ppt/slides/slide17.xml><?xml version="1.0" encoding="utf-8"?>
 <p:sld xmlns:a="http://schemas.openxmlformats.org/drawingml/2006/main" xmlns:p="http://schemas.openxmlformats.org/presentationml/2006/main" xmlns:r="http://schemas.openxmlformats.org/officeDocument/2006/relationships">
   <p:cSld>
     <p:bg>
@@ -7180,7 +7181,7 @@
               </a:defRPr>
             </a:pPr>
             <a:r>
-              <a:t>RANGKUMAN &amp; KEY TAKEAWAYS</a:t>
+              <a:t>PT SINERGI GULA NUSANTARA (SGN)</a:t>
             </a:r>
           </a:p>
           <a:p>
@@ -7193,21 +7194,339 @@
               </a:defRPr>
             </a:pPr>
             <a:r>
-              <a:t>5 Poin Penting yang Harus Diingat</a:t>
-            </a:r>
-          </a:p>
-        </p:txBody>
-      </p:sp>
-      <p:sp>
-        <p:nvSpPr>
-          <p:cNvPr id="3" name="Rounded Rectangle 2"/>
+              <a:t>SugarCo — Holding Pabrik Gula BUMN Indonesia</a:t>
+            </a:r>
+          </a:p>
+        </p:txBody>
+      </p:sp>
+      <p:sp>
+        <p:nvSpPr>
+          <p:cNvPr id="3" name="TextBox 2"/>
+          <p:cNvSpPr txBox="1"/>
+          <p:nvPr/>
+        </p:nvSpPr>
+        <p:spPr>
+          <a:xfrm>
+            <a:off x="731520" y="1463040"/>
+            <a:ext cx="6858000" cy="5303520"/>
+          </a:xfrm>
+          <a:prstGeom prst="rect">
+            <a:avLst/>
+          </a:prstGeom>
+          <a:noFill/>
+        </p:spPr>
+        <p:txBody>
+          <a:bodyPr wrap="square">
+            <a:spAutoFit/>
+          </a:bodyPr>
+          <a:lstStyle/>
+          <a:p>
+            <a:pPr>
+              <a:spcAft>
+                <a:spcPts val="800"/>
+              </a:spcAft>
+              <a:defRPr sz="1200">
+                <a:solidFill>
+                  <a:srgbClr val="212121"/>
+                </a:solidFill>
+                <a:latin typeface="Calibri"/>
+              </a:defRPr>
+            </a:pPr>
+            <a:r>
+              <a:t>▪ Didirikan: 17 Agustus 2021 di bawah PTPN III (Holding)</a:t>
+            </a:r>
+          </a:p>
+          <a:p>
+            <a:pPr>
+              <a:spcAft>
+                <a:spcPts val="800"/>
+              </a:spcAft>
+              <a:defRPr sz="1200">
+                <a:solidFill>
+                  <a:srgbClr val="212121"/>
+                </a:solidFill>
+                <a:latin typeface="Calibri"/>
+              </a:defRPr>
+            </a:pPr>
+            <a:r>
+              <a:t>▪ Nama resmi: PT Sinergi Gula Nusantara (SGN)</a:t>
+            </a:r>
+          </a:p>
+          <a:p>
+            <a:pPr>
+              <a:spcAft>
+                <a:spcPts val="800"/>
+              </a:spcAft>
+              <a:defRPr sz="1200">
+                <a:solidFill>
+                  <a:srgbClr val="212121"/>
+                </a:solidFill>
+                <a:latin typeface="Calibri"/>
+              </a:defRPr>
+            </a:pPr>
+            <a:r>
+              <a:t>▪ Bagian dari 88 Program Kementerian BUMN 2020-2023</a:t>
+            </a:r>
+          </a:p>
+          <a:p>
+            <a:pPr>
+              <a:spcAft>
+                <a:spcPts val="800"/>
+              </a:spcAft>
+              <a:defRPr sz="1200">
+                <a:solidFill>
+                  <a:srgbClr val="212121"/>
+                </a:solidFill>
+                <a:latin typeface="Calibri"/>
+              </a:defRPr>
+            </a:pPr>
+            <a:r>
+              <a:t>▪ Misi: Pencapaian Swasembada Gula Nasional</a:t>
+            </a:r>
+          </a:p>
+          <a:p>
+            <a:pPr>
+              <a:spcAft>
+                <a:spcPts val="800"/>
+              </a:spcAft>
+              <a:defRPr sz="1200">
+                <a:solidFill>
+                  <a:srgbClr val="212121"/>
+                </a:solidFill>
+                <a:latin typeface="Calibri"/>
+              </a:defRPr>
+            </a:pPr>
+          </a:p>
+          <a:p>
+            <a:pPr>
+              <a:spcAft>
+                <a:spcPts val="800"/>
+              </a:spcAft>
+              <a:defRPr sz="1200">
+                <a:solidFill>
+                  <a:srgbClr val="212121"/>
+                </a:solidFill>
+                <a:latin typeface="Calibri"/>
+              </a:defRPr>
+            </a:pPr>
+            <a:r>
+              <a:t>▪ Skala Operasi:</a:t>
+            </a:r>
+          </a:p>
+          <a:p>
+            <a:pPr>
+              <a:spcAft>
+                <a:spcPts val="800"/>
+              </a:spcAft>
+              <a:defRPr sz="1200">
+                <a:solidFill>
+                  <a:srgbClr val="212121"/>
+                </a:solidFill>
+                <a:latin typeface="Calibri"/>
+              </a:defRPr>
+            </a:pPr>
+            <a:r>
+              <a:t>   – 43 Pabrik Gula tersebar di Jawa &amp; luar Jawa</a:t>
+            </a:r>
+          </a:p>
+          <a:p>
+            <a:pPr>
+              <a:spcAft>
+                <a:spcPts val="800"/>
+              </a:spcAft>
+              <a:defRPr sz="1200">
+                <a:solidFill>
+                  <a:srgbClr val="212121"/>
+                </a:solidFill>
+                <a:latin typeface="Calibri"/>
+              </a:defRPr>
+            </a:pPr>
+            <a:r>
+              <a:t>   – Areal HGU/TS: ~56.000 hektar</a:t>
+            </a:r>
+          </a:p>
+          <a:p>
+            <a:pPr>
+              <a:spcAft>
+                <a:spcPts val="800"/>
+              </a:spcAft>
+              <a:defRPr sz="1200">
+                <a:solidFill>
+                  <a:srgbClr val="212121"/>
+                </a:solidFill>
+                <a:latin typeface="Calibri"/>
+              </a:defRPr>
+            </a:pPr>
+            <a:r>
+              <a:t>   – Berasal dari 7 anak perusahaan PTPN</a:t>
+            </a:r>
+          </a:p>
+          <a:p>
+            <a:pPr>
+              <a:spcAft>
+                <a:spcPts val="800"/>
+              </a:spcAft>
+              <a:defRPr sz="1200">
+                <a:solidFill>
+                  <a:srgbClr val="212121"/>
+                </a:solidFill>
+                <a:latin typeface="Calibri"/>
+              </a:defRPr>
+            </a:pPr>
+          </a:p>
+          <a:p>
+            <a:pPr>
+              <a:spcAft>
+                <a:spcPts val="800"/>
+              </a:spcAft>
+              <a:defRPr sz="1200">
+                <a:solidFill>
+                  <a:srgbClr val="212121"/>
+                </a:solidFill>
+                <a:latin typeface="Calibri"/>
+              </a:defRPr>
+            </a:pPr>
+            <a:r>
+              <a:t>▪ Tantangan yang Dihadapi SGN:</a:t>
+            </a:r>
+          </a:p>
+          <a:p>
+            <a:pPr>
+              <a:spcAft>
+                <a:spcPts val="800"/>
+              </a:spcAft>
+              <a:defRPr sz="1200">
+                <a:solidFill>
+                  <a:srgbClr val="212121"/>
+                </a:solidFill>
+                <a:latin typeface="Calibri"/>
+              </a:defRPr>
+            </a:pPr>
+            <a:r>
+              <a:t>   – Aspek operasi belum terstandarisasi</a:t>
+            </a:r>
+          </a:p>
+          <a:p>
+            <a:pPr>
+              <a:spcAft>
+                <a:spcPts val="800"/>
+              </a:spcAft>
+              <a:defRPr sz="1200">
+                <a:solidFill>
+                  <a:srgbClr val="212121"/>
+                </a:solidFill>
+                <a:latin typeface="Calibri"/>
+              </a:defRPr>
+            </a:pPr>
+            <a:r>
+              <a:t>   – Skala &amp; utilisasi pabrik bervariasi</a:t>
+            </a:r>
+          </a:p>
+          <a:p>
+            <a:pPr>
+              <a:spcAft>
+                <a:spcPts val="800"/>
+              </a:spcAft>
+              <a:defRPr sz="1200">
+                <a:solidFill>
+                  <a:srgbClr val="212121"/>
+                </a:solidFill>
+                <a:latin typeface="Calibri"/>
+              </a:defRPr>
+            </a:pPr>
+            <a:r>
+              <a:t>   – Ketergantungan supply tebu petani rakyat</a:t>
+            </a:r>
+          </a:p>
+          <a:p>
+            <a:pPr>
+              <a:spcAft>
+                <a:spcPts val="800"/>
+              </a:spcAft>
+              <a:defRPr sz="1200">
+                <a:solidFill>
+                  <a:srgbClr val="212121"/>
+                </a:solidFill>
+                <a:latin typeface="Calibri"/>
+              </a:defRPr>
+            </a:pPr>
+          </a:p>
+          <a:p>
+            <a:pPr>
+              <a:spcAft>
+                <a:spcPts val="800"/>
+              </a:spcAft>
+              <a:defRPr sz="1200">
+                <a:solidFill>
+                  <a:srgbClr val="212121"/>
+                </a:solidFill>
+                <a:latin typeface="Calibri"/>
+              </a:defRPr>
+            </a:pPr>
+            <a:r>
+              <a:t>▪ Inisiatif Strategis:</a:t>
+            </a:r>
+          </a:p>
+          <a:p>
+            <a:pPr>
+              <a:spcAft>
+                <a:spcPts val="800"/>
+              </a:spcAft>
+              <a:defRPr sz="1200">
+                <a:solidFill>
+                  <a:srgbClr val="212121"/>
+                </a:solidFill>
+                <a:latin typeface="Calibri"/>
+              </a:defRPr>
+            </a:pPr>
+            <a:r>
+              <a:t>   – Kolaborasi bioetanol dengan Pertamina NRE (2024)</a:t>
+            </a:r>
+          </a:p>
+          <a:p>
+            <a:pPr>
+              <a:spcAft>
+                <a:spcPts val="800"/>
+              </a:spcAft>
+              <a:defRPr sz="1200">
+                <a:solidFill>
+                  <a:srgbClr val="212121"/>
+                </a:solidFill>
+                <a:latin typeface="Calibri"/>
+              </a:defRPr>
+            </a:pPr>
+            <a:r>
+              <a:t>   – Kerjasama UGM untuk optimasi lahan KHDTK</a:t>
+            </a:r>
+          </a:p>
+          <a:p>
+            <a:pPr>
+              <a:spcAft>
+                <a:spcPts val="800"/>
+              </a:spcAft>
+              <a:defRPr sz="1200">
+                <a:solidFill>
+                  <a:srgbClr val="212121"/>
+                </a:solidFill>
+                <a:latin typeface="Calibri"/>
+              </a:defRPr>
+            </a:pPr>
+            <a:r>
+              <a:t>   – Digitalisasi via SIMPG, HCIS, ERMS, e-Contract</a:t>
+            </a:r>
+          </a:p>
+        </p:txBody>
+      </p:sp>
+      <p:sp>
+        <p:nvSpPr>
+          <p:cNvPr id="4" name="Rounded Rectangle 3"/>
           <p:cNvSpPr/>
           <p:nvPr/>
         </p:nvSpPr>
         <p:spPr>
           <a:xfrm>
-            <a:off x="548640" y="1463040"/>
-            <a:ext cx="548640" cy="548640"/>
+            <a:off x="8229600" y="1645920"/>
+            <a:ext cx="3474720" cy="1005840"/>
           </a:xfrm>
           <a:prstGeom prst="roundRect">
             <a:avLst/>
@@ -7239,7 +7558,7 @@
           <a:lstStyle/>
           <a:p>
             <a:pPr algn="ctr">
-              <a:defRPr sz="1800" b="1">
+              <a:defRPr sz="1100" b="1">
                 <a:solidFill>
                   <a:srgbClr val="FFFFFF"/>
                 </a:solidFill>
@@ -7247,56 +7566,15 @@
               </a:defRPr>
             </a:pPr>
             <a:r>
-              <a:t>1</a:t>
-            </a:r>
-          </a:p>
-        </p:txBody>
-      </p:sp>
-      <p:sp>
-        <p:nvSpPr>
-          <p:cNvPr id="4" name="TextBox 3"/>
-          <p:cNvSpPr txBox="1"/>
-          <p:nvPr/>
-        </p:nvSpPr>
-        <p:spPr>
-          <a:xfrm>
-            <a:off x="1280160" y="1463040"/>
-            <a:ext cx="10058400" cy="822960"/>
-          </a:xfrm>
-          <a:prstGeom prst="rect">
-            <a:avLst/>
-          </a:prstGeom>
-          <a:noFill/>
-        </p:spPr>
-        <p:txBody>
-          <a:bodyPr wrap="square">
-            <a:spAutoFit/>
-          </a:bodyPr>
-          <a:lstStyle/>
-          <a:p>
-            <a:pPr>
-              <a:defRPr sz="1600" b="1">
-                <a:solidFill>
-                  <a:srgbClr val="1B5E20"/>
-                </a:solidFill>
-                <a:latin typeface="Calibri"/>
-              </a:defRPr>
-            </a:pPr>
-            <a:r>
-              <a:t>Bisnis Terintegrasi</a:t>
-            </a:r>
-          </a:p>
-          <a:p>
-            <a:pPr>
-              <a:defRPr sz="1200">
-                <a:solidFill>
-                  <a:srgbClr val="212121"/>
-                </a:solidFill>
-                <a:latin typeface="Calibri"/>
-              </a:defRPr>
-            </a:pPr>
-            <a:r>
-              <a:t>Pabrik gula = hulu (kebun) + proses (pabrik) + hilir (distribusi). Satu rantai nilai yang saling tergantung.</a:t>
+              <a:t>JAWA TIMUR</a:t>
+            </a:r>
+            <a:br/>
+            <a:r>
+              <a:t>PG terbanyak: Ngadirejo,</a:t>
+            </a:r>
+            <a:br/>
+            <a:r>
+              <a:t>Djatiroto, Semboro, dll.</a:t>
             </a:r>
           </a:p>
         </p:txBody>
@@ -7309,8 +7587,8 @@
         </p:nvSpPr>
         <p:spPr>
           <a:xfrm>
-            <a:off x="548640" y="2468880"/>
-            <a:ext cx="548640" cy="548640"/>
+            <a:off x="8229600" y="2880360"/>
+            <a:ext cx="3474720" cy="1005840"/>
           </a:xfrm>
           <a:prstGeom prst="roundRect">
             <a:avLst/>
@@ -7342,7 +7620,7 @@
           <a:lstStyle/>
           <a:p>
             <a:pPr algn="ctr">
-              <a:defRPr sz="1800" b="1">
+              <a:defRPr sz="1100" b="1">
                 <a:solidFill>
                   <a:srgbClr val="FFFFFF"/>
                 </a:solidFill>
@@ -7350,70 +7628,29 @@
               </a:defRPr>
             </a:pPr>
             <a:r>
-              <a:t>2</a:t>
-            </a:r>
-          </a:p>
-        </p:txBody>
-      </p:sp>
-      <p:sp>
-        <p:nvSpPr>
-          <p:cNvPr id="6" name="TextBox 5"/>
-          <p:cNvSpPr txBox="1"/>
-          <p:nvPr/>
-        </p:nvSpPr>
-        <p:spPr>
-          <a:xfrm>
-            <a:off x="1280160" y="2468880"/>
-            <a:ext cx="10058400" cy="822960"/>
-          </a:xfrm>
-          <a:prstGeom prst="rect">
-            <a:avLst/>
-          </a:prstGeom>
-          <a:noFill/>
-        </p:spPr>
-        <p:txBody>
-          <a:bodyPr wrap="square">
-            <a:spAutoFit/>
-          </a:bodyPr>
-          <a:lstStyle/>
-          <a:p>
-            <a:pPr>
-              <a:defRPr sz="1600" b="1">
-                <a:solidFill>
-                  <a:srgbClr val="2E7D32"/>
-                </a:solidFill>
-                <a:latin typeface="Calibri"/>
-              </a:defRPr>
-            </a:pPr>
-            <a:r>
-              <a:t>Multi-Revenue Stream</a:t>
-            </a:r>
-          </a:p>
-          <a:p>
-            <a:pPr>
-              <a:defRPr sz="1200">
-                <a:solidFill>
-                  <a:srgbClr val="212121"/>
-                </a:solidFill>
-                <a:latin typeface="Calibri"/>
-              </a:defRPr>
-            </a:pPr>
-            <a:r>
-              <a:t>Bukan hanya gula — molasses, bagasse, blotong, dan listrik menyumbang 15–25% revenue tambahan.</a:t>
-            </a:r>
-          </a:p>
-        </p:txBody>
-      </p:sp>
-      <p:sp>
-        <p:nvSpPr>
-          <p:cNvPr id="7" name="Rounded Rectangle 6"/>
+              <a:t>JAWA TENGAH</a:t>
+            </a:r>
+            <a:br/>
+            <a:r>
+              <a:t>PG Comal, Sragi,</a:t>
+            </a:r>
+            <a:br/>
+            <a:r>
+              <a:t>Tasikmadu, dll.</a:t>
+            </a:r>
+          </a:p>
+        </p:txBody>
+      </p:sp>
+      <p:sp>
+        <p:nvSpPr>
+          <p:cNvPr id="6" name="Rounded Rectangle 5"/>
           <p:cNvSpPr/>
           <p:nvPr/>
         </p:nvSpPr>
         <p:spPr>
           <a:xfrm>
-            <a:off x="548640" y="3474720"/>
-            <a:ext cx="548640" cy="548640"/>
+            <a:off x="8229600" y="4114800"/>
+            <a:ext cx="3474720" cy="1005840"/>
           </a:xfrm>
           <a:prstGeom prst="roundRect">
             <a:avLst/>
@@ -7445,7 +7682,7 @@
           <a:lstStyle/>
           <a:p>
             <a:pPr algn="ctr">
-              <a:defRPr sz="1800" b="1">
+              <a:defRPr sz="1100" b="1">
                 <a:solidFill>
                   <a:srgbClr val="FFFFFF"/>
                 </a:solidFill>
@@ -7453,70 +7690,29 @@
               </a:defRPr>
             </a:pPr>
             <a:r>
-              <a:t>3</a:t>
-            </a:r>
-          </a:p>
-        </p:txBody>
-      </p:sp>
-      <p:sp>
-        <p:nvSpPr>
-          <p:cNvPr id="8" name="TextBox 7"/>
-          <p:cNvSpPr txBox="1"/>
-          <p:nvPr/>
-        </p:nvSpPr>
-        <p:spPr>
-          <a:xfrm>
-            <a:off x="1280160" y="3474720"/>
-            <a:ext cx="10058400" cy="822960"/>
-          </a:xfrm>
-          <a:prstGeom prst="rect">
-            <a:avLst/>
-          </a:prstGeom>
-          <a:noFill/>
-        </p:spPr>
-        <p:txBody>
-          <a:bodyPr wrap="square">
-            <a:spAutoFit/>
-          </a:bodyPr>
-          <a:lstStyle/>
-          <a:p>
-            <a:pPr>
-              <a:defRPr sz="1600" b="1">
-                <a:solidFill>
-                  <a:srgbClr val="7CB342"/>
-                </a:solidFill>
-                <a:latin typeface="Calibri"/>
-              </a:defRPr>
-            </a:pPr>
-            <a:r>
-              <a:t>KPI Raja = Rendemen</a:t>
-            </a:r>
-          </a:p>
-          <a:p>
-            <a:pPr>
-              <a:defRPr sz="1200">
-                <a:solidFill>
-                  <a:srgbClr val="212121"/>
-                </a:solidFill>
-                <a:latin typeface="Calibri"/>
-              </a:defRPr>
-            </a:pPr>
-            <a:r>
-              <a:t>Target 8–10%. Kenaikan 1% rendemen = peningkatan profit signifikan. Semua stasiun berkontribusi.</a:t>
-            </a:r>
-          </a:p>
-        </p:txBody>
-      </p:sp>
-      <p:sp>
-        <p:nvSpPr>
-          <p:cNvPr id="9" name="Rounded Rectangle 8"/>
+              <a:t>JAWA BARAT</a:t>
+            </a:r>
+            <a:br/>
+            <a:r>
+              <a:t>PG Subang, Rajawali,</a:t>
+            </a:r>
+            <a:br/>
+            <a:r>
+              <a:t>Jatitujuh, dll.</a:t>
+            </a:r>
+          </a:p>
+        </p:txBody>
+      </p:sp>
+      <p:sp>
+        <p:nvSpPr>
+          <p:cNvPr id="7" name="Rounded Rectangle 6"/>
           <p:cNvSpPr/>
           <p:nvPr/>
         </p:nvSpPr>
         <p:spPr>
           <a:xfrm>
-            <a:off x="548640" y="4480560"/>
-            <a:ext cx="548640" cy="548640"/>
+            <a:off x="8229600" y="5349240"/>
+            <a:ext cx="3474720" cy="1005840"/>
           </a:xfrm>
           <a:prstGeom prst="roundRect">
             <a:avLst/>
@@ -7548,7 +7744,7 @@
           <a:lstStyle/>
           <a:p>
             <a:pPr algn="ctr">
-              <a:defRPr sz="1800" b="1">
+              <a:defRPr sz="1100" b="1">
                 <a:solidFill>
                   <a:srgbClr val="FFFFFF"/>
                 </a:solidFill>
@@ -7556,76 +7752,39 @@
               </a:defRPr>
             </a:pPr>
             <a:r>
-              <a:t>4</a:t>
-            </a:r>
-          </a:p>
-        </p:txBody>
-      </p:sp>
-      <p:sp>
-        <p:nvSpPr>
-          <p:cNvPr id="10" name="TextBox 9"/>
-          <p:cNvSpPr txBox="1"/>
-          <p:nvPr/>
-        </p:nvSpPr>
-        <p:spPr>
-          <a:xfrm>
-            <a:off x="1280160" y="4480560"/>
-            <a:ext cx="10058400" cy="822960"/>
-          </a:xfrm>
-          <a:prstGeom prst="rect">
-            <a:avLst/>
-          </a:prstGeom>
-          <a:noFill/>
-        </p:spPr>
-        <p:txBody>
-          <a:bodyPr wrap="square">
-            <a:spAutoFit/>
-          </a:bodyPr>
-          <a:lstStyle/>
-          <a:p>
-            <a:pPr>
-              <a:defRPr sz="1600" b="1">
-                <a:solidFill>
-                  <a:srgbClr val="C68A02"/>
-                </a:solidFill>
-                <a:latin typeface="Calibri"/>
-              </a:defRPr>
-            </a:pPr>
-            <a:r>
-              <a:t>Tantangan Nyata</a:t>
-            </a:r>
-          </a:p>
-          <a:p>
-            <a:pPr>
-              <a:defRPr sz="1200">
-                <a:solidFill>
-                  <a:srgbClr val="212121"/>
-                </a:solidFill>
-                <a:latin typeface="Calibri"/>
-              </a:defRPr>
-            </a:pPr>
-            <a:r>
-              <a:t>Produktivitas rendah, teknologi tua, margin tipis. Indonesia masih impor 50% gula.</a:t>
-            </a:r>
-          </a:p>
-        </p:txBody>
-      </p:sp>
-      <p:sp>
-        <p:nvSpPr>
-          <p:cNvPr id="11" name="Rounded Rectangle 10"/>
+              <a:t>LAMPUNG &amp;</a:t>
+            </a:r>
+            <a:br/>
+            <a:r>
+              <a:t>LUAR JAWA</a:t>
+            </a:r>
+            <a:br/>
+            <a:r>
+              <a:t>PG Bunga Mayang,</a:t>
+            </a:r>
+            <a:br/>
+            <a:r>
+              <a:t>NTT (bioetanol)</a:t>
+            </a:r>
+          </a:p>
+        </p:txBody>
+      </p:sp>
+      <p:sp>
+        <p:nvSpPr>
+          <p:cNvPr id="8" name="Rounded Rectangle 7"/>
           <p:cNvSpPr/>
           <p:nvPr/>
         </p:nvSpPr>
         <p:spPr>
           <a:xfrm>
-            <a:off x="548640" y="5486400"/>
-            <a:ext cx="548640" cy="548640"/>
+            <a:off x="548640" y="5943600"/>
+            <a:ext cx="2743200" cy="777240"/>
           </a:xfrm>
           <a:prstGeom prst="roundRect">
             <a:avLst/>
           </a:prstGeom>
           <a:solidFill>
-            <a:srgbClr val="6D4C00"/>
+            <a:srgbClr val="1B5E20"/>
           </a:solidFill>
           <a:ln>
             <a:noFill/>
@@ -7651,7 +7810,7 @@
           <a:lstStyle/>
           <a:p>
             <a:pPr algn="ctr">
-              <a:defRPr sz="1800" b="1">
+              <a:defRPr sz="1100" b="1">
                 <a:solidFill>
                   <a:srgbClr val="FFFFFF"/>
                 </a:solidFill>
@@ -7659,92 +7818,189 @@
               </a:defRPr>
             </a:pPr>
             <a:r>
-              <a:t>5</a:t>
-            </a:r>
-          </a:p>
-        </p:txBody>
-      </p:sp>
-      <p:sp>
-        <p:nvSpPr>
-          <p:cNvPr id="12" name="TextBox 11"/>
-          <p:cNvSpPr txBox="1"/>
-          <p:nvPr/>
-        </p:nvSpPr>
-        <p:spPr>
-          <a:xfrm>
-            <a:off x="1280160" y="5486400"/>
-            <a:ext cx="10058400" cy="822960"/>
-          </a:xfrm>
-          <a:prstGeom prst="rect">
-            <a:avLst/>
-          </a:prstGeom>
-          <a:noFill/>
-        </p:spPr>
-        <p:txBody>
-          <a:bodyPr wrap="square">
-            <a:spAutoFit/>
-          </a:bodyPr>
-          <a:lstStyle/>
-          <a:p>
-            <a:pPr>
-              <a:defRPr sz="1600" b="1">
-                <a:solidFill>
-                  <a:srgbClr val="6D4C00"/>
-                </a:solidFill>
-                <a:latin typeface="Calibri"/>
-              </a:defRPr>
-            </a:pPr>
-            <a:r>
-              <a:t>Peluang Besar</a:t>
-            </a:r>
-          </a:p>
-          <a:p>
-            <a:pPr>
-              <a:defRPr sz="1200">
-                <a:solidFill>
-                  <a:srgbClr val="212121"/>
-                </a:solidFill>
-                <a:latin typeface="Calibri"/>
-              </a:defRPr>
-            </a:pPr>
-            <a:r>
-              <a:t>Digitalisasi, modernisasi, co-gen, diversifikasi → potensi +20–30% EBITDA.</a:t>
-            </a:r>
-          </a:p>
-        </p:txBody>
-      </p:sp>
-      <p:sp>
-        <p:nvSpPr>
-          <p:cNvPr id="13" name="TextBox 12"/>
-          <p:cNvSpPr txBox="1"/>
-          <p:nvPr/>
-        </p:nvSpPr>
-        <p:spPr>
-          <a:xfrm>
-            <a:off x="914400" y="6400800"/>
-            <a:ext cx="10058400" cy="365760"/>
-          </a:xfrm>
-          <a:prstGeom prst="rect">
-            <a:avLst/>
-          </a:prstGeom>
-          <a:noFill/>
-        </p:spPr>
-        <p:txBody>
-          <a:bodyPr wrap="none">
-            <a:spAutoFit/>
-          </a:bodyPr>
+              <a:t>43</a:t>
+            </a:r>
+            <a:br/>
+            <a:r>
+              <a:t>Pabrik Gula</a:t>
+            </a:r>
+          </a:p>
+        </p:txBody>
+      </p:sp>
+      <p:sp>
+        <p:nvSpPr>
+          <p:cNvPr id="9" name="Rounded Rectangle 8"/>
+          <p:cNvSpPr/>
+          <p:nvPr/>
+        </p:nvSpPr>
+        <p:spPr>
+          <a:xfrm>
+            <a:off x="3474720" y="5943600"/>
+            <a:ext cx="2743200" cy="777240"/>
+          </a:xfrm>
+          <a:prstGeom prst="roundRect">
+            <a:avLst/>
+          </a:prstGeom>
+          <a:solidFill>
+            <a:srgbClr val="2E7D32"/>
+          </a:solidFill>
+          <a:ln>
+            <a:noFill/>
+          </a:ln>
+          <a:effectLst/>
+        </p:spPr>
+        <p:style>
+          <a:lnRef idx="1">
+            <a:schemeClr val="accent1"/>
+          </a:lnRef>
+          <a:fillRef idx="3">
+            <a:schemeClr val="accent1"/>
+          </a:fillRef>
+          <a:effectRef idx="2">
+            <a:schemeClr val="accent1"/>
+          </a:effectRef>
+          <a:fontRef idx="minor">
+            <a:schemeClr val="lt1"/>
+          </a:fontRef>
+        </p:style>
+        <p:txBody>
+          <a:bodyPr rtlCol="0" anchor="ctr" wrap="square" tIns="76200" bIns="76200" lIns="101600" rIns="101600"/>
           <a:lstStyle/>
           <a:p>
             <a:pPr algn="ctr">
-              <a:defRPr sz="1300" i="1">
-                <a:solidFill>
-                  <a:srgbClr val="757575"/>
-                </a:solidFill>
-                <a:latin typeface="Calibri"/>
-              </a:defRPr>
-            </a:pPr>
-            <a:r>
-              <a:t>"100 ton tebu → 8–10 ton gula + 30 ton bagasse + 4–5 ton molasses = bisnis yang utuh"</a:t>
+              <a:defRPr sz="1100" b="1">
+                <a:solidFill>
+                  <a:srgbClr val="FFFFFF"/>
+                </a:solidFill>
+                <a:latin typeface="Calibri"/>
+              </a:defRPr>
+            </a:pPr>
+            <a:r>
+              <a:t>56.000 ha</a:t>
+            </a:r>
+            <a:br/>
+            <a:r>
+              <a:t>Areal Tebu</a:t>
+            </a:r>
+          </a:p>
+        </p:txBody>
+      </p:sp>
+      <p:sp>
+        <p:nvSpPr>
+          <p:cNvPr id="10" name="Rounded Rectangle 9"/>
+          <p:cNvSpPr/>
+          <p:nvPr/>
+        </p:nvSpPr>
+        <p:spPr>
+          <a:xfrm>
+            <a:off x="6400800" y="5943600"/>
+            <a:ext cx="2743200" cy="777240"/>
+          </a:xfrm>
+          <a:prstGeom prst="roundRect">
+            <a:avLst/>
+          </a:prstGeom>
+          <a:solidFill>
+            <a:srgbClr val="7CB342"/>
+          </a:solidFill>
+          <a:ln>
+            <a:noFill/>
+          </a:ln>
+          <a:effectLst/>
+        </p:spPr>
+        <p:style>
+          <a:lnRef idx="1">
+            <a:schemeClr val="accent1"/>
+          </a:lnRef>
+          <a:fillRef idx="3">
+            <a:schemeClr val="accent1"/>
+          </a:fillRef>
+          <a:effectRef idx="2">
+            <a:schemeClr val="accent1"/>
+          </a:effectRef>
+          <a:fontRef idx="minor">
+            <a:schemeClr val="lt1"/>
+          </a:fontRef>
+        </p:style>
+        <p:txBody>
+          <a:bodyPr rtlCol="0" anchor="ctr" wrap="square" tIns="76200" bIns="76200" lIns="101600" rIns="101600"/>
+          <a:lstStyle/>
+          <a:p>
+            <a:pPr algn="ctr">
+              <a:defRPr sz="1100" b="1">
+                <a:solidFill>
+                  <a:srgbClr val="FFFFFF"/>
+                </a:solidFill>
+                <a:latin typeface="Calibri"/>
+              </a:defRPr>
+            </a:pPr>
+            <a:r>
+              <a:t>7 PTPN</a:t>
+            </a:r>
+            <a:br/>
+            <a:r>
+              <a:t>Subsidiari Asal</a:t>
+            </a:r>
+          </a:p>
+        </p:txBody>
+      </p:sp>
+      <p:sp>
+        <p:nvSpPr>
+          <p:cNvPr id="11" name="Rounded Rectangle 10"/>
+          <p:cNvSpPr/>
+          <p:nvPr/>
+        </p:nvSpPr>
+        <p:spPr>
+          <a:xfrm>
+            <a:off x="9326880" y="5943600"/>
+            <a:ext cx="2743200" cy="777240"/>
+          </a:xfrm>
+          <a:prstGeom prst="roundRect">
+            <a:avLst/>
+          </a:prstGeom>
+          <a:solidFill>
+            <a:srgbClr val="C68A02"/>
+          </a:solidFill>
+          <a:ln>
+            <a:noFill/>
+          </a:ln>
+          <a:effectLst/>
+        </p:spPr>
+        <p:style>
+          <a:lnRef idx="1">
+            <a:schemeClr val="accent1"/>
+          </a:lnRef>
+          <a:fillRef idx="3">
+            <a:schemeClr val="accent1"/>
+          </a:fillRef>
+          <a:effectRef idx="2">
+            <a:schemeClr val="accent1"/>
+          </a:effectRef>
+          <a:fontRef idx="minor">
+            <a:schemeClr val="lt1"/>
+          </a:fontRef>
+        </p:style>
+        <p:txBody>
+          <a:bodyPr rtlCol="0" anchor="ctr" wrap="square" tIns="76200" bIns="76200" lIns="101600" rIns="101600"/>
+          <a:lstStyle/>
+          <a:p>
+            <a:pPr algn="ctr">
+              <a:defRPr sz="1100" b="1">
+                <a:solidFill>
+                  <a:srgbClr val="FFFFFF"/>
+                </a:solidFill>
+                <a:latin typeface="Calibri"/>
+              </a:defRPr>
+            </a:pPr>
+            <a:r>
+              <a:t>Target:</a:t>
+            </a:r>
+            <a:br/>
+            <a:r>
+              <a:t>Swasembada</a:t>
+            </a:r>
+            <a:br/>
+            <a:r>
+              <a:t>Gula 2025-2026</a:t>
             </a:r>
           </a:p>
         </p:txBody>
@@ -7757,7 +8013,718 @@
 </p:sld>
 </file>
 
-<file path=ppt/slides/slide16.xml><?xml version="1.0" encoding="utf-8"?>
+<file path=ppt/slides/slide18.xml><?xml version="1.0" encoding="utf-8"?>
+<p:sld xmlns:a="http://schemas.openxmlformats.org/drawingml/2006/main" xmlns:p="http://schemas.openxmlformats.org/presentationml/2006/main" xmlns:r="http://schemas.openxmlformats.org/officeDocument/2006/relationships">
+  <p:cSld>
+    <p:bg>
+      <p:bgPr>
+        <a:solidFill>
+          <a:srgbClr val="FFFFFF"/>
+        </a:solidFill>
+        <a:effectLst/>
+      </p:bgPr>
+    </p:bg>
+    <p:spTree>
+      <p:nvGrpSpPr>
+        <p:cNvPr id="1" name=""/>
+        <p:cNvGrpSpPr/>
+        <p:nvPr/>
+      </p:nvGrpSpPr>
+      <p:grpSpPr/>
+      <p:sp>
+        <p:nvSpPr>
+          <p:cNvPr id="2" name="Rectangle 1"/>
+          <p:cNvSpPr/>
+          <p:nvPr/>
+        </p:nvSpPr>
+        <p:spPr>
+          <a:xfrm>
+            <a:off x="0" y="0"/>
+            <a:ext cx="12191695" cy="1188720"/>
+          </a:xfrm>
+          <a:prstGeom prst="rect">
+            <a:avLst/>
+          </a:prstGeom>
+          <a:solidFill>
+            <a:srgbClr val="1B5E20"/>
+          </a:solidFill>
+          <a:ln>
+            <a:noFill/>
+          </a:ln>
+          <a:effectLst/>
+        </p:spPr>
+        <p:style>
+          <a:lnRef idx="1">
+            <a:schemeClr val="accent1"/>
+          </a:lnRef>
+          <a:fillRef idx="3">
+            <a:schemeClr val="accent1"/>
+          </a:fillRef>
+          <a:effectRef idx="2">
+            <a:schemeClr val="accent1"/>
+          </a:effectRef>
+          <a:fontRef idx="minor">
+            <a:schemeClr val="lt1"/>
+          </a:fontRef>
+        </p:style>
+        <p:txBody>
+          <a:bodyPr rtlCol="0" anchor="ctr" tIns="203200" lIns="508000"/>
+          <a:lstStyle/>
+          <a:p>
+            <a:pPr algn="ctr">
+              <a:defRPr sz="2800" b="1">
+                <a:solidFill>
+                  <a:srgbClr val="FFFFFF"/>
+                </a:solidFill>
+                <a:latin typeface="Calibri"/>
+              </a:defRPr>
+            </a:pPr>
+            <a:r>
+              <a:t>RANGKUMAN &amp; KEY TAKEAWAYS</a:t>
+            </a:r>
+          </a:p>
+          <a:p>
+            <a:pPr>
+              <a:defRPr sz="1400">
+                <a:solidFill>
+                  <a:srgbClr val="C8E6C9"/>
+                </a:solidFill>
+                <a:latin typeface="Calibri"/>
+              </a:defRPr>
+            </a:pPr>
+            <a:r>
+              <a:t>6 Poin Penting yang Harus Diingat</a:t>
+            </a:r>
+          </a:p>
+        </p:txBody>
+      </p:sp>
+      <p:sp>
+        <p:nvSpPr>
+          <p:cNvPr id="3" name="Rounded Rectangle 2"/>
+          <p:cNvSpPr/>
+          <p:nvPr/>
+        </p:nvSpPr>
+        <p:spPr>
+          <a:xfrm>
+            <a:off x="548640" y="1371600"/>
+            <a:ext cx="502920" cy="502920"/>
+          </a:xfrm>
+          <a:prstGeom prst="roundRect">
+            <a:avLst/>
+          </a:prstGeom>
+          <a:solidFill>
+            <a:srgbClr val="1B5E20"/>
+          </a:solidFill>
+          <a:ln>
+            <a:noFill/>
+          </a:ln>
+          <a:effectLst/>
+        </p:spPr>
+        <p:style>
+          <a:lnRef idx="1">
+            <a:schemeClr val="accent1"/>
+          </a:lnRef>
+          <a:fillRef idx="3">
+            <a:schemeClr val="accent1"/>
+          </a:fillRef>
+          <a:effectRef idx="2">
+            <a:schemeClr val="accent1"/>
+          </a:effectRef>
+          <a:fontRef idx="minor">
+            <a:schemeClr val="lt1"/>
+          </a:fontRef>
+        </p:style>
+        <p:txBody>
+          <a:bodyPr rtlCol="0" anchor="ctr" wrap="square" tIns="76200" bIns="76200" lIns="101600" rIns="101600"/>
+          <a:lstStyle/>
+          <a:p>
+            <a:pPr algn="ctr">
+              <a:defRPr sz="1600" b="1">
+                <a:solidFill>
+                  <a:srgbClr val="FFFFFF"/>
+                </a:solidFill>
+                <a:latin typeface="Calibri"/>
+              </a:defRPr>
+            </a:pPr>
+            <a:r>
+              <a:t>1</a:t>
+            </a:r>
+          </a:p>
+        </p:txBody>
+      </p:sp>
+      <p:sp>
+        <p:nvSpPr>
+          <p:cNvPr id="4" name="TextBox 3"/>
+          <p:cNvSpPr txBox="1"/>
+          <p:nvPr/>
+        </p:nvSpPr>
+        <p:spPr>
+          <a:xfrm>
+            <a:off x="1188720" y="1371600"/>
+            <a:ext cx="10058400" cy="777240"/>
+          </a:xfrm>
+          <a:prstGeom prst="rect">
+            <a:avLst/>
+          </a:prstGeom>
+          <a:noFill/>
+        </p:spPr>
+        <p:txBody>
+          <a:bodyPr wrap="square">
+            <a:spAutoFit/>
+          </a:bodyPr>
+          <a:lstStyle/>
+          <a:p>
+            <a:pPr>
+              <a:defRPr sz="1500" b="1">
+                <a:solidFill>
+                  <a:srgbClr val="1B5E20"/>
+                </a:solidFill>
+                <a:latin typeface="Calibri"/>
+              </a:defRPr>
+            </a:pPr>
+            <a:r>
+              <a:t>Bisnis Terintegrasi</a:t>
+            </a:r>
+          </a:p>
+          <a:p>
+            <a:pPr>
+              <a:defRPr sz="1100">
+                <a:solidFill>
+                  <a:srgbClr val="212121"/>
+                </a:solidFill>
+                <a:latin typeface="Calibri"/>
+              </a:defRPr>
+            </a:pPr>
+            <a:r>
+              <a:t>Pabrik gula = hulu (kebun) + proses (pabrik) + hilir (distribusi). Satu rantai nilai yang saling tergantung.</a:t>
+            </a:r>
+          </a:p>
+        </p:txBody>
+      </p:sp>
+      <p:sp>
+        <p:nvSpPr>
+          <p:cNvPr id="5" name="Rounded Rectangle 4"/>
+          <p:cNvSpPr/>
+          <p:nvPr/>
+        </p:nvSpPr>
+        <p:spPr>
+          <a:xfrm>
+            <a:off x="548640" y="2240280"/>
+            <a:ext cx="502920" cy="502920"/>
+          </a:xfrm>
+          <a:prstGeom prst="roundRect">
+            <a:avLst/>
+          </a:prstGeom>
+          <a:solidFill>
+            <a:srgbClr val="2E7D32"/>
+          </a:solidFill>
+          <a:ln>
+            <a:noFill/>
+          </a:ln>
+          <a:effectLst/>
+        </p:spPr>
+        <p:style>
+          <a:lnRef idx="1">
+            <a:schemeClr val="accent1"/>
+          </a:lnRef>
+          <a:fillRef idx="3">
+            <a:schemeClr val="accent1"/>
+          </a:fillRef>
+          <a:effectRef idx="2">
+            <a:schemeClr val="accent1"/>
+          </a:effectRef>
+          <a:fontRef idx="minor">
+            <a:schemeClr val="lt1"/>
+          </a:fontRef>
+        </p:style>
+        <p:txBody>
+          <a:bodyPr rtlCol="0" anchor="ctr" wrap="square" tIns="76200" bIns="76200" lIns="101600" rIns="101600"/>
+          <a:lstStyle/>
+          <a:p>
+            <a:pPr algn="ctr">
+              <a:defRPr sz="1600" b="1">
+                <a:solidFill>
+                  <a:srgbClr val="FFFFFF"/>
+                </a:solidFill>
+                <a:latin typeface="Calibri"/>
+              </a:defRPr>
+            </a:pPr>
+            <a:r>
+              <a:t>2</a:t>
+            </a:r>
+          </a:p>
+        </p:txBody>
+      </p:sp>
+      <p:sp>
+        <p:nvSpPr>
+          <p:cNvPr id="6" name="TextBox 5"/>
+          <p:cNvSpPr txBox="1"/>
+          <p:nvPr/>
+        </p:nvSpPr>
+        <p:spPr>
+          <a:xfrm>
+            <a:off x="1188720" y="2240280"/>
+            <a:ext cx="10058400" cy="777240"/>
+          </a:xfrm>
+          <a:prstGeom prst="rect">
+            <a:avLst/>
+          </a:prstGeom>
+          <a:noFill/>
+        </p:spPr>
+        <p:txBody>
+          <a:bodyPr wrap="square">
+            <a:spAutoFit/>
+          </a:bodyPr>
+          <a:lstStyle/>
+          <a:p>
+            <a:pPr>
+              <a:defRPr sz="1500" b="1">
+                <a:solidFill>
+                  <a:srgbClr val="2E7D32"/>
+                </a:solidFill>
+                <a:latin typeface="Calibri"/>
+              </a:defRPr>
+            </a:pPr>
+            <a:r>
+              <a:t>Multi-Revenue Stream</a:t>
+            </a:r>
+          </a:p>
+          <a:p>
+            <a:pPr>
+              <a:defRPr sz="1100">
+                <a:solidFill>
+                  <a:srgbClr val="212121"/>
+                </a:solidFill>
+                <a:latin typeface="Calibri"/>
+              </a:defRPr>
+            </a:pPr>
+            <a:r>
+              <a:t>Bukan hanya gula — molasses, bagasse, blotong, dan listrik menyumbang 15-25% revenue tambahan.</a:t>
+            </a:r>
+          </a:p>
+        </p:txBody>
+      </p:sp>
+      <p:sp>
+        <p:nvSpPr>
+          <p:cNvPr id="7" name="Rounded Rectangle 6"/>
+          <p:cNvSpPr/>
+          <p:nvPr/>
+        </p:nvSpPr>
+        <p:spPr>
+          <a:xfrm>
+            <a:off x="548640" y="3108960"/>
+            <a:ext cx="502920" cy="502920"/>
+          </a:xfrm>
+          <a:prstGeom prst="roundRect">
+            <a:avLst/>
+          </a:prstGeom>
+          <a:solidFill>
+            <a:srgbClr val="7CB342"/>
+          </a:solidFill>
+          <a:ln>
+            <a:noFill/>
+          </a:ln>
+          <a:effectLst/>
+        </p:spPr>
+        <p:style>
+          <a:lnRef idx="1">
+            <a:schemeClr val="accent1"/>
+          </a:lnRef>
+          <a:fillRef idx="3">
+            <a:schemeClr val="accent1"/>
+          </a:fillRef>
+          <a:effectRef idx="2">
+            <a:schemeClr val="accent1"/>
+          </a:effectRef>
+          <a:fontRef idx="minor">
+            <a:schemeClr val="lt1"/>
+          </a:fontRef>
+        </p:style>
+        <p:txBody>
+          <a:bodyPr rtlCol="0" anchor="ctr" wrap="square" tIns="76200" bIns="76200" lIns="101600" rIns="101600"/>
+          <a:lstStyle/>
+          <a:p>
+            <a:pPr algn="ctr">
+              <a:defRPr sz="1600" b="1">
+                <a:solidFill>
+                  <a:srgbClr val="FFFFFF"/>
+                </a:solidFill>
+                <a:latin typeface="Calibri"/>
+              </a:defRPr>
+            </a:pPr>
+            <a:r>
+              <a:t>3</a:t>
+            </a:r>
+          </a:p>
+        </p:txBody>
+      </p:sp>
+      <p:sp>
+        <p:nvSpPr>
+          <p:cNvPr id="8" name="TextBox 7"/>
+          <p:cNvSpPr txBox="1"/>
+          <p:nvPr/>
+        </p:nvSpPr>
+        <p:spPr>
+          <a:xfrm>
+            <a:off x="1188720" y="3108960"/>
+            <a:ext cx="10058400" cy="777240"/>
+          </a:xfrm>
+          <a:prstGeom prst="rect">
+            <a:avLst/>
+          </a:prstGeom>
+          <a:noFill/>
+        </p:spPr>
+        <p:txBody>
+          <a:bodyPr wrap="square">
+            <a:spAutoFit/>
+          </a:bodyPr>
+          <a:lstStyle/>
+          <a:p>
+            <a:pPr>
+              <a:defRPr sz="1500" b="1">
+                <a:solidFill>
+                  <a:srgbClr val="7CB342"/>
+                </a:solidFill>
+                <a:latin typeface="Calibri"/>
+              </a:defRPr>
+            </a:pPr>
+            <a:r>
+              <a:t>KPI Raja = Rendemen</a:t>
+            </a:r>
+          </a:p>
+          <a:p>
+            <a:pPr>
+              <a:defRPr sz="1100">
+                <a:solidFill>
+                  <a:srgbClr val="212121"/>
+                </a:solidFill>
+                <a:latin typeface="Calibri"/>
+              </a:defRPr>
+            </a:pPr>
+            <a:r>
+              <a:t>Target 8-10%. Kenaikan 1% rendemen = peningkatan profit signifikan.</a:t>
+            </a:r>
+          </a:p>
+        </p:txBody>
+      </p:sp>
+      <p:sp>
+        <p:nvSpPr>
+          <p:cNvPr id="9" name="Rounded Rectangle 8"/>
+          <p:cNvSpPr/>
+          <p:nvPr/>
+        </p:nvSpPr>
+        <p:spPr>
+          <a:xfrm>
+            <a:off x="548640" y="3977640"/>
+            <a:ext cx="502920" cy="502920"/>
+          </a:xfrm>
+          <a:prstGeom prst="roundRect">
+            <a:avLst/>
+          </a:prstGeom>
+          <a:solidFill>
+            <a:srgbClr val="4CAF50"/>
+          </a:solidFill>
+          <a:ln>
+            <a:noFill/>
+          </a:ln>
+          <a:effectLst/>
+        </p:spPr>
+        <p:style>
+          <a:lnRef idx="1">
+            <a:schemeClr val="accent1"/>
+          </a:lnRef>
+          <a:fillRef idx="3">
+            <a:schemeClr val="accent1"/>
+          </a:fillRef>
+          <a:effectRef idx="2">
+            <a:schemeClr val="accent1"/>
+          </a:effectRef>
+          <a:fontRef idx="minor">
+            <a:schemeClr val="lt1"/>
+          </a:fontRef>
+        </p:style>
+        <p:txBody>
+          <a:bodyPr rtlCol="0" anchor="ctr" wrap="square" tIns="76200" bIns="76200" lIns="101600" rIns="101600"/>
+          <a:lstStyle/>
+          <a:p>
+            <a:pPr algn="ctr">
+              <a:defRPr sz="1600" b="1">
+                <a:solidFill>
+                  <a:srgbClr val="FFFFFF"/>
+                </a:solidFill>
+                <a:latin typeface="Calibri"/>
+              </a:defRPr>
+            </a:pPr>
+            <a:r>
+              <a:t>4</a:t>
+            </a:r>
+          </a:p>
+        </p:txBody>
+      </p:sp>
+      <p:sp>
+        <p:nvSpPr>
+          <p:cNvPr id="10" name="TextBox 9"/>
+          <p:cNvSpPr txBox="1"/>
+          <p:nvPr/>
+        </p:nvSpPr>
+        <p:spPr>
+          <a:xfrm>
+            <a:off x="1188720" y="3977640"/>
+            <a:ext cx="10058400" cy="777240"/>
+          </a:xfrm>
+          <a:prstGeom prst="rect">
+            <a:avLst/>
+          </a:prstGeom>
+          <a:noFill/>
+        </p:spPr>
+        <p:txBody>
+          <a:bodyPr wrap="square">
+            <a:spAutoFit/>
+          </a:bodyPr>
+          <a:lstStyle/>
+          <a:p>
+            <a:pPr>
+              <a:defRPr sz="1500" b="1">
+                <a:solidFill>
+                  <a:srgbClr val="4CAF50"/>
+                </a:solidFill>
+                <a:latin typeface="Calibri"/>
+              </a:defRPr>
+            </a:pPr>
+            <a:r>
+              <a:t>SGN: 43 Pabrik Gula</a:t>
+            </a:r>
+          </a:p>
+          <a:p>
+            <a:pPr>
+              <a:defRPr sz="1100">
+                <a:solidFill>
+                  <a:srgbClr val="212121"/>
+                </a:solidFill>
+                <a:latin typeface="Calibri"/>
+              </a:defRPr>
+            </a:pPr>
+            <a:r>
+              <a:t>PT Sinergi Gula Nusantara mengelola 43 PG dari 7 PTPN, areal 56 ribu ha, menuju swasembada gula.</a:t>
+            </a:r>
+          </a:p>
+        </p:txBody>
+      </p:sp>
+      <p:sp>
+        <p:nvSpPr>
+          <p:cNvPr id="11" name="Rounded Rectangle 10"/>
+          <p:cNvSpPr/>
+          <p:nvPr/>
+        </p:nvSpPr>
+        <p:spPr>
+          <a:xfrm>
+            <a:off x="548640" y="4846320"/>
+            <a:ext cx="502920" cy="502920"/>
+          </a:xfrm>
+          <a:prstGeom prst="roundRect">
+            <a:avLst/>
+          </a:prstGeom>
+          <a:solidFill>
+            <a:srgbClr val="C68A02"/>
+          </a:solidFill>
+          <a:ln>
+            <a:noFill/>
+          </a:ln>
+          <a:effectLst/>
+        </p:spPr>
+        <p:style>
+          <a:lnRef idx="1">
+            <a:schemeClr val="accent1"/>
+          </a:lnRef>
+          <a:fillRef idx="3">
+            <a:schemeClr val="accent1"/>
+          </a:fillRef>
+          <a:effectRef idx="2">
+            <a:schemeClr val="accent1"/>
+          </a:effectRef>
+          <a:fontRef idx="minor">
+            <a:schemeClr val="lt1"/>
+          </a:fontRef>
+        </p:style>
+        <p:txBody>
+          <a:bodyPr rtlCol="0" anchor="ctr" wrap="square" tIns="76200" bIns="76200" lIns="101600" rIns="101600"/>
+          <a:lstStyle/>
+          <a:p>
+            <a:pPr algn="ctr">
+              <a:defRPr sz="1600" b="1">
+                <a:solidFill>
+                  <a:srgbClr val="FFFFFF"/>
+                </a:solidFill>
+                <a:latin typeface="Calibri"/>
+              </a:defRPr>
+            </a:pPr>
+            <a:r>
+              <a:t>5</a:t>
+            </a:r>
+          </a:p>
+        </p:txBody>
+      </p:sp>
+      <p:sp>
+        <p:nvSpPr>
+          <p:cNvPr id="12" name="TextBox 11"/>
+          <p:cNvSpPr txBox="1"/>
+          <p:nvPr/>
+        </p:nvSpPr>
+        <p:spPr>
+          <a:xfrm>
+            <a:off x="1188720" y="4846320"/>
+            <a:ext cx="10058400" cy="777240"/>
+          </a:xfrm>
+          <a:prstGeom prst="rect">
+            <a:avLst/>
+          </a:prstGeom>
+          <a:noFill/>
+        </p:spPr>
+        <p:txBody>
+          <a:bodyPr wrap="square">
+            <a:spAutoFit/>
+          </a:bodyPr>
+          <a:lstStyle/>
+          <a:p>
+            <a:pPr>
+              <a:defRPr sz="1500" b="1">
+                <a:solidFill>
+                  <a:srgbClr val="C68A02"/>
+                </a:solidFill>
+                <a:latin typeface="Calibri"/>
+              </a:defRPr>
+            </a:pPr>
+            <a:r>
+              <a:t>Tantangan Nyata</a:t>
+            </a:r>
+          </a:p>
+          <a:p>
+            <a:pPr>
+              <a:defRPr sz="1100">
+                <a:solidFill>
+                  <a:srgbClr val="212121"/>
+                </a:solidFill>
+                <a:latin typeface="Calibri"/>
+              </a:defRPr>
+            </a:pPr>
+            <a:r>
+              <a:t>Produktivitas rendah, teknologi tua, margin tipis. Indonesia masih impor 50% gula.</a:t>
+            </a:r>
+          </a:p>
+        </p:txBody>
+      </p:sp>
+      <p:sp>
+        <p:nvSpPr>
+          <p:cNvPr id="13" name="Rounded Rectangle 12"/>
+          <p:cNvSpPr/>
+          <p:nvPr/>
+        </p:nvSpPr>
+        <p:spPr>
+          <a:xfrm>
+            <a:off x="548640" y="5715000"/>
+            <a:ext cx="502920" cy="502920"/>
+          </a:xfrm>
+          <a:prstGeom prst="roundRect">
+            <a:avLst/>
+          </a:prstGeom>
+          <a:solidFill>
+            <a:srgbClr val="6D4C00"/>
+          </a:solidFill>
+          <a:ln>
+            <a:noFill/>
+          </a:ln>
+          <a:effectLst/>
+        </p:spPr>
+        <p:style>
+          <a:lnRef idx="1">
+            <a:schemeClr val="accent1"/>
+          </a:lnRef>
+          <a:fillRef idx="3">
+            <a:schemeClr val="accent1"/>
+          </a:fillRef>
+          <a:effectRef idx="2">
+            <a:schemeClr val="accent1"/>
+          </a:effectRef>
+          <a:fontRef idx="minor">
+            <a:schemeClr val="lt1"/>
+          </a:fontRef>
+        </p:style>
+        <p:txBody>
+          <a:bodyPr rtlCol="0" anchor="ctr" wrap="square" tIns="76200" bIns="76200" lIns="101600" rIns="101600"/>
+          <a:lstStyle/>
+          <a:p>
+            <a:pPr algn="ctr">
+              <a:defRPr sz="1600" b="1">
+                <a:solidFill>
+                  <a:srgbClr val="FFFFFF"/>
+                </a:solidFill>
+                <a:latin typeface="Calibri"/>
+              </a:defRPr>
+            </a:pPr>
+            <a:r>
+              <a:t>6</a:t>
+            </a:r>
+          </a:p>
+        </p:txBody>
+      </p:sp>
+      <p:sp>
+        <p:nvSpPr>
+          <p:cNvPr id="14" name="TextBox 13"/>
+          <p:cNvSpPr txBox="1"/>
+          <p:nvPr/>
+        </p:nvSpPr>
+        <p:spPr>
+          <a:xfrm>
+            <a:off x="1188720" y="5715000"/>
+            <a:ext cx="10058400" cy="777240"/>
+          </a:xfrm>
+          <a:prstGeom prst="rect">
+            <a:avLst/>
+          </a:prstGeom>
+          <a:noFill/>
+        </p:spPr>
+        <p:txBody>
+          <a:bodyPr wrap="square">
+            <a:spAutoFit/>
+          </a:bodyPr>
+          <a:lstStyle/>
+          <a:p>
+            <a:pPr>
+              <a:defRPr sz="1500" b="1">
+                <a:solidFill>
+                  <a:srgbClr val="6D4C00"/>
+                </a:solidFill>
+                <a:latin typeface="Calibri"/>
+              </a:defRPr>
+            </a:pPr>
+            <a:r>
+              <a:t>Peluang Besar</a:t>
+            </a:r>
+          </a:p>
+          <a:p>
+            <a:pPr>
+              <a:defRPr sz="1100">
+                <a:solidFill>
+                  <a:srgbClr val="212121"/>
+                </a:solidFill>
+                <a:latin typeface="Calibri"/>
+              </a:defRPr>
+            </a:pPr>
+            <a:r>
+              <a:t>Digitalisasi, modernisasi, co-gen, diversifikasi, bioetanol -&gt; potensi +20-30% EBITDA.</a:t>
+            </a:r>
+          </a:p>
+        </p:txBody>
+      </p:sp>
+    </p:spTree>
+  </p:cSld>
+  <p:clrMapOvr>
+    <a:masterClrMapping/>
+  </p:clrMapOvr>
+</p:sld>
+</file>
+
+<file path=ppt/slides/slide19.xml><?xml version="1.0" encoding="utf-8"?>
 <p:sld xmlns:a="http://schemas.openxmlformats.org/drawingml/2006/main" xmlns:p="http://schemas.openxmlformats.org/presentationml/2006/main" xmlns:r="http://schemas.openxmlformats.org/officeDocument/2006/relationships">
   <p:cSld>
     <p:bg>
@@ -7913,6 +8880,42 @@
             </a:pPr>
             <a:r>
               <a:t>Silakan ajukan pertanyaan atau berikan masukan</a:t>
+            </a:r>
+          </a:p>
+        </p:txBody>
+      </p:sp>
+      <p:sp>
+        <p:nvSpPr>
+          <p:cNvPr id="5" name="TextBox 4"/>
+          <p:cNvSpPr txBox="1"/>
+          <p:nvPr/>
+        </p:nvSpPr>
+        <p:spPr>
+          <a:xfrm>
+            <a:off x="1828800" y="6217920"/>
+            <a:ext cx="8229600" cy="457200"/>
+          </a:xfrm>
+          <a:prstGeom prst="rect">
+            <a:avLst/>
+          </a:prstGeom>
+          <a:noFill/>
+        </p:spPr>
+        <p:txBody>
+          <a:bodyPr wrap="none">
+            <a:spAutoFit/>
+          </a:bodyPr>
+          <a:lstStyle/>
+          <a:p>
+            <a:pPr algn="ctr">
+              <a:defRPr sz="1000">
+                <a:solidFill>
+                  <a:srgbClr val="81C784"/>
+                </a:solidFill>
+                <a:latin typeface="Calibri"/>
+              </a:defRPr>
+            </a:pPr>
+            <a:r>
+              <a:t>Sumber data SGN: sinergigula.com | The Jakarta Post | UGM.ac.id</a:t>
             </a:r>
           </a:p>
         </p:txBody>

</xml_diff>